<commit_message>
Remove author mentions and improve readability QA
</commit_message>
<xml_diff>
--- a/recency-latency-retention-crm-lecture-full-workshop-v3-final.pptx
+++ b/recency-latency-retention-crm-lecture-full-workshop-v3-final.pptx
@@ -3254,7 +3254,7 @@
                 </a:solidFill>
                 <a:latin typeface="Pretendard"/>
               </a:rPr>
-              <a:t>Jim Novo 원문 기반 Recency / Latency 리텐션 분석과 CRM 자동화</a:t>
+              <a:t>고객 행동 데이터 기반 Recency / Latency 리텐션 분석과 CRM 자동화</a:t>
             </a:r>
           </a:p>
         </p:txBody>
@@ -3340,7 +3340,7 @@
                   <a:srgbClr val="FFFFFF"/>
                 </a:solidFill>
               </a:rPr>
-              <a:t>기반: Jim Novo, *Drilling Down: Turning Customer Data into Profits with a Spreadsheet*, 3rd ed. PDF 원문 반영</a:t>
+              <a:t>기반: 고객 행동 데이터 분석 원문 사례 및 PDF 원문 반영</a:t>
             </a:r>
           </a:p>
           <a:p>
@@ -4242,7 +4242,7 @@
               </a:defRPr>
             </a:pPr>
             <a:r>
-              <a:t>Jim Novo의 Online Retail 사례에서 고객 분포는 이렇게 보였습니다.</a:t>
+              <a:t>Online Retail 사례에서 고객 분포는 이렇게 보였습니다.</a:t>
             </a:r>
           </a:p>
           <a:p>
@@ -14253,174 +14253,334 @@
       </p:sp>
       <p:sp>
         <p:nvSpPr>
-          <p:cNvPr id="4" name="TextBox 3"/>
-          <p:cNvSpPr txBox="1"/>
-          <p:nvPr/>
-        </p:nvSpPr>
-        <p:spPr>
-          <a:xfrm>
-            <a:off x="822960" y="1261872"/>
-            <a:ext cx="10698480" cy="4251960"/>
-          </a:xfrm>
-          <a:prstGeom prst="rect">
-            <a:avLst/>
-          </a:prstGeom>
-          <a:noFill/>
-        </p:spPr>
-        <p:txBody>
-          <a:bodyPr wrap="square">
-            <a:normAutofit/>
-          </a:bodyPr>
-          <a:lstStyle/>
-          <a:p>
-            <a:pPr>
-              <a:spcAft>
-                <a:spcPts val="800"/>
-              </a:spcAft>
-              <a:defRPr sz="2100">
-                <a:solidFill>
-                  <a:srgbClr val="212529"/>
-                </a:solidFill>
-                <a:latin typeface="Pretendard"/>
-              </a:defRPr>
-            </a:pPr>
-            <a:r>
-              <a:t>필요한 테이블 구조:</a:t>
-            </a:r>
-          </a:p>
-          <a:p>
-            <a:pPr>
-              <a:spcAft>
-                <a:spcPts val="800"/>
-              </a:spcAft>
-              <a:defRPr sz="2100">
-                <a:solidFill>
-                  <a:srgbClr val="212529"/>
-                </a:solidFill>
-                <a:latin typeface="Pretendard"/>
-              </a:defRPr>
-            </a:pPr>
-            <a:r>
-              <a:t>핵심 쿼리:</a:t>
-            </a:r>
-          </a:p>
-          <a:p>
-            <a:pPr>
-              <a:spcAft>
-                <a:spcPts val="800"/>
-              </a:spcAft>
-              <a:defRPr sz="2100">
-                <a:solidFill>
-                  <a:srgbClr val="212529"/>
-                </a:solidFill>
-                <a:latin typeface="Pretendard"/>
-              </a:defRPr>
-            </a:pPr>
-            <a:r>
-              <a:t>user_id</a:t>
-            </a:r>
-          </a:p>
-          <a:p>
-            <a:pPr>
-              <a:spcAft>
-                <a:spcPts val="800"/>
-              </a:spcAft>
-              <a:defRPr sz="2100">
-                <a:solidFill>
-                  <a:srgbClr val="212529"/>
-                </a:solidFill>
-                <a:latin typeface="Pretendard"/>
-              </a:defRPr>
-            </a:pPr>
-            <a:r>
-              <a:t>event_name</a:t>
-            </a:r>
-          </a:p>
-          <a:p>
-            <a:pPr>
-              <a:spcAft>
-                <a:spcPts val="800"/>
-              </a:spcAft>
-              <a:defRPr sz="2100">
-                <a:solidFill>
-                  <a:srgbClr val="212529"/>
-                </a:solidFill>
-                <a:latin typeface="Pretendard"/>
-              </a:defRPr>
-            </a:pPr>
-            <a:r>
-              <a:t>event_time</a:t>
-            </a:r>
-          </a:p>
-          <a:p>
-            <a:pPr>
-              <a:spcAft>
-                <a:spcPts val="800"/>
-              </a:spcAft>
-              <a:defRPr sz="2100">
-                <a:solidFill>
-                  <a:srgbClr val="212529"/>
-                </a:solidFill>
-                <a:latin typeface="Pretendard"/>
-              </a:defRPr>
-            </a:pPr>
-            <a:r>
-              <a:t>event_index</a:t>
-            </a:r>
-          </a:p>
-          <a:p>
-            <a:pPr>
-              <a:spcAft>
-                <a:spcPts val="800"/>
-              </a:spcAft>
-              <a:defRPr sz="2100">
-                <a:solidFill>
-                  <a:srgbClr val="212529"/>
-                </a:solidFill>
-                <a:latin typeface="Pretendard"/>
-              </a:defRPr>
-            </a:pPr>
-            <a:r>
-              <a:t>previous_event_time</a:t>
-            </a:r>
-          </a:p>
-          <a:p>
-            <a:pPr>
-              <a:spcAft>
-                <a:spcPts val="800"/>
-              </a:spcAft>
-              <a:defRPr sz="2100">
-                <a:solidFill>
-                  <a:srgbClr val="212529"/>
-                </a:solidFill>
-                <a:latin typeface="Pretendard"/>
-              </a:defRPr>
-            </a:pPr>
-            <a:r>
-              <a:t>days_since_previous_event</a:t>
-            </a:r>
-          </a:p>
-          <a:p>
-            <a:pPr>
-              <a:spcAft>
-                <a:spcPts val="800"/>
-              </a:spcAft>
-              <a:defRPr sz="2100">
-                <a:solidFill>
-                  <a:srgbClr val="212529"/>
-                </a:solidFill>
-                <a:latin typeface="Pretendard"/>
-              </a:defRPr>
-            </a:pPr>
-            <a:r>
-              <a:t>days_since_last_key_event</a:t>
-            </a:r>
+          <p:cNvPr id="4" name="Rectangle 3"/>
+          <p:cNvSpPr/>
+          <p:nvPr/>
+        </p:nvSpPr>
+        <p:spPr>
+          <a:xfrm>
+            <a:off x="685800" y="1261872"/>
+            <a:ext cx="10835640" cy="685800"/>
+          </a:xfrm>
+          <a:prstGeom prst="rect">
+            <a:avLst/>
+          </a:prstGeom>
+          <a:solidFill>
+            <a:srgbClr val="FFF7E6"/>
+          </a:solidFill>
+          <a:ln>
+            <a:solidFill>
+              <a:srgbClr val="FF9900"/>
+            </a:solidFill>
+          </a:ln>
+        </p:spPr>
+        <p:style>
+          <a:lnRef idx="1">
+            <a:schemeClr val="accent1"/>
+          </a:lnRef>
+          <a:fillRef idx="3">
+            <a:schemeClr val="accent1"/>
+          </a:fillRef>
+          <a:effectRef idx="2">
+            <a:schemeClr val="accent1"/>
+          </a:effectRef>
+          <a:fontRef idx="minor">
+            <a:schemeClr val="lt1"/>
+          </a:fontRef>
+        </p:style>
+        <p:txBody>
+          <a:bodyPr rtlCol="0" anchor="ctr"/>
+          <a:lstStyle/>
+          <a:p>
+            <a:pPr algn="ctr"/>
           </a:p>
         </p:txBody>
       </p:sp>
       <p:sp>
         <p:nvSpPr>
           <p:cNvPr id="5" name="TextBox 4"/>
+          <p:cNvSpPr txBox="1"/>
+          <p:nvPr/>
+        </p:nvSpPr>
+        <p:spPr>
+          <a:xfrm>
+            <a:off x="914400" y="1380744"/>
+            <a:ext cx="10287000" cy="384048"/>
+          </a:xfrm>
+          <a:prstGeom prst="rect">
+            <a:avLst/>
+          </a:prstGeom>
+          <a:noFill/>
+        </p:spPr>
+        <p:txBody>
+          <a:bodyPr wrap="square">
+            <a:normAutofit/>
+          </a:bodyPr>
+          <a:lstStyle/>
+          <a:p>
+            <a:r>
+              <a:rPr sz="2100" b="1">
+                <a:solidFill>
+                  <a:srgbClr val="3B2A00"/>
+                </a:solidFill>
+                <a:latin typeface="Pretendard"/>
+              </a:rPr>
+              <a:t>LAG()로 이전 행동을 찾고, DATE_DIFF()로 Recency/Latency를 만든 뒤, bucket별 profit을 집계합니다.</a:t>
+            </a:r>
+          </a:p>
+        </p:txBody>
+      </p:sp>
+      <p:sp>
+        <p:nvSpPr>
+          <p:cNvPr id="6" name="TextBox 5"/>
+          <p:cNvSpPr txBox="1"/>
+          <p:nvPr/>
+        </p:nvSpPr>
+        <p:spPr>
+          <a:xfrm>
+            <a:off x="777240" y="2157984"/>
+            <a:ext cx="5989320" cy="4343400"/>
+          </a:xfrm>
+          <a:prstGeom prst="rect">
+            <a:avLst/>
+          </a:prstGeom>
+          <a:noFill/>
+        </p:spPr>
+        <p:txBody>
+          <a:bodyPr wrap="square">
+            <a:normAutofit/>
+          </a:bodyPr>
+          <a:lstStyle/>
+          <a:p>
+            <a:pPr>
+              <a:spcAft>
+                <a:spcPts val="800"/>
+              </a:spcAft>
+              <a:defRPr sz="1900">
+                <a:solidFill>
+                  <a:srgbClr val="212529"/>
+                </a:solidFill>
+                <a:latin typeface="Pretendard"/>
+              </a:defRPr>
+            </a:pPr>
+            <a:r>
+              <a:t>목표: 이벤트 로그를 고객별 시간 구조로 바꿉니다.</a:t>
+            </a:r>
+          </a:p>
+          <a:p>
+            <a:pPr>
+              <a:spcAft>
+                <a:spcPts val="800"/>
+              </a:spcAft>
+              <a:defRPr sz="1900">
+                <a:solidFill>
+                  <a:srgbClr val="212529"/>
+                </a:solidFill>
+                <a:latin typeface="Pretendard"/>
+              </a:defRPr>
+            </a:pPr>
+            <a:r>
+              <a:t>필수 필드:</a:t>
+            </a:r>
+          </a:p>
+          <a:p>
+            <a:pPr>
+              <a:spcAft>
+                <a:spcPts val="800"/>
+              </a:spcAft>
+              <a:defRPr sz="1900">
+                <a:solidFill>
+                  <a:srgbClr val="212529"/>
+                </a:solidFill>
+                <a:latin typeface="Pretendard"/>
+              </a:defRPr>
+            </a:pPr>
+            <a:r>
+              <a:t>핵심 계산:</a:t>
+            </a:r>
+          </a:p>
+          <a:p>
+            <a:pPr>
+              <a:spcAft>
+                <a:spcPts val="800"/>
+              </a:spcAft>
+              <a:defRPr sz="1900">
+                <a:solidFill>
+                  <a:srgbClr val="212529"/>
+                </a:solidFill>
+                <a:latin typeface="Pretendard"/>
+              </a:defRPr>
+            </a:pPr>
+            <a:r>
+              <a:t>user_id, event_name, event_time</a:t>
+            </a:r>
+          </a:p>
+          <a:p>
+            <a:pPr>
+              <a:spcAft>
+                <a:spcPts val="800"/>
+              </a:spcAft>
+              <a:defRPr sz="1900">
+                <a:solidFill>
+                  <a:srgbClr val="212529"/>
+                </a:solidFill>
+                <a:latin typeface="Pretendard"/>
+              </a:defRPr>
+            </a:pPr>
+            <a:r>
+              <a:t>event_index, previous_event_time</a:t>
+            </a:r>
+          </a:p>
+          <a:p>
+            <a:pPr>
+              <a:spcAft>
+                <a:spcPts val="800"/>
+              </a:spcAft>
+              <a:defRPr sz="1900">
+                <a:solidFill>
+                  <a:srgbClr val="212529"/>
+                </a:solidFill>
+                <a:latin typeface="Pretendard"/>
+              </a:defRPr>
+            </a:pPr>
+            <a:r>
+              <a:t>days_since_previous_event, days_since_last_key_event</a:t>
+            </a:r>
+          </a:p>
+          <a:p>
+            <a:pPr>
+              <a:spcAft>
+                <a:spcPts val="800"/>
+              </a:spcAft>
+              <a:defRPr sz="1900">
+                <a:solidFill>
+                  <a:srgbClr val="212529"/>
+                </a:solidFill>
+                <a:latin typeface="Pretendard"/>
+              </a:defRPr>
+            </a:pPr>
+            <a:r>
+              <a:t>segment_key, revenue, margin</a:t>
+            </a:r>
+          </a:p>
+        </p:txBody>
+      </p:sp>
+      <p:sp>
+        <p:nvSpPr>
+          <p:cNvPr id="7" name="Rectangle 6"/>
+          <p:cNvSpPr/>
+          <p:nvPr/>
+        </p:nvSpPr>
+        <p:spPr>
+          <a:xfrm>
+            <a:off x="7086600" y="2157984"/>
+            <a:ext cx="4389120" cy="3246120"/>
+          </a:xfrm>
+          <a:prstGeom prst="rect">
+            <a:avLst/>
+          </a:prstGeom>
+          <a:solidFill>
+            <a:srgbClr val="EFF6FF"/>
+          </a:solidFill>
+          <a:ln>
+            <a:solidFill>
+              <a:srgbClr val="BFDBFE"/>
+            </a:solidFill>
+          </a:ln>
+        </p:spPr>
+        <p:style>
+          <a:lnRef idx="1">
+            <a:schemeClr val="accent1"/>
+          </a:lnRef>
+          <a:fillRef idx="3">
+            <a:schemeClr val="accent1"/>
+          </a:fillRef>
+          <a:effectRef idx="2">
+            <a:schemeClr val="accent1"/>
+          </a:effectRef>
+          <a:fontRef idx="minor">
+            <a:schemeClr val="lt1"/>
+          </a:fontRef>
+        </p:style>
+        <p:txBody>
+          <a:bodyPr rtlCol="0" anchor="ctr"/>
+          <a:lstStyle/>
+          <a:p>
+            <a:pPr algn="ctr"/>
+          </a:p>
+        </p:txBody>
+      </p:sp>
+      <p:sp>
+        <p:nvSpPr>
+          <p:cNvPr id="8" name="TextBox 7"/>
+          <p:cNvSpPr txBox="1"/>
+          <p:nvPr/>
+        </p:nvSpPr>
+        <p:spPr>
+          <a:xfrm>
+            <a:off x="7360920" y="2386584"/>
+            <a:ext cx="3840480" cy="320040"/>
+          </a:xfrm>
+          <a:prstGeom prst="rect">
+            <a:avLst/>
+          </a:prstGeom>
+          <a:noFill/>
+        </p:spPr>
+        <p:txBody>
+          <a:bodyPr wrap="square">
+            <a:normAutofit/>
+          </a:bodyPr>
+          <a:lstStyle/>
+          <a:p>
+            <a:r>
+              <a:rPr sz="1600" b="1">
+                <a:solidFill>
+                  <a:srgbClr val="007BFF"/>
+                </a:solidFill>
+                <a:latin typeface="Pretendard"/>
+              </a:rPr>
+              <a:t>Visual Guide</a:t>
+            </a:r>
+          </a:p>
+        </p:txBody>
+      </p:sp>
+      <p:sp>
+        <p:nvSpPr>
+          <p:cNvPr id="9" name="TextBox 8"/>
+          <p:cNvSpPr txBox="1"/>
+          <p:nvPr/>
+        </p:nvSpPr>
+        <p:spPr>
+          <a:xfrm>
+            <a:off x="7360920" y="2843784"/>
+            <a:ext cx="3794760" cy="2057400"/>
+          </a:xfrm>
+          <a:prstGeom prst="rect">
+            <a:avLst/>
+          </a:prstGeom>
+          <a:noFill/>
+        </p:spPr>
+        <p:txBody>
+          <a:bodyPr wrap="square">
+            <a:normAutofit/>
+          </a:bodyPr>
+          <a:lstStyle/>
+          <a:p>
+            <a:r>
+              <a:rPr sz="1600" b="0">
+                <a:solidFill>
+                  <a:srgbClr val="0B2D5B"/>
+                </a:solidFill>
+                <a:latin typeface="Pretendard"/>
+              </a:rPr>
+              <a:t>raw event log → user sequence table → bucket profit table 3단 변환 도식</a:t>
+            </a:r>
+          </a:p>
+        </p:txBody>
+      </p:sp>
+      <p:sp>
+        <p:nvSpPr>
+          <p:cNvPr id="10" name="TextBox 9"/>
           <p:cNvSpPr txBox="1"/>
           <p:nvPr/>
         </p:nvSpPr>
@@ -18338,7 +18498,7 @@
                 </a:solidFill>
                 <a:latin typeface="Pretendard"/>
               </a:rPr>
-              <a:t>Jim Novo의 핵심 전환</a:t>
+              <a:t>핵심 전환</a:t>
             </a:r>
           </a:p>
         </p:txBody>

</xml_diff>

<commit_message>
Package full workshop materials and polish readability
</commit_message>
<xml_diff>
--- a/recency-latency-retention-crm-lecture-full-workshop-v3-final.pptx
+++ b/recency-latency-retention-crm-lecture-full-workshop-v3-final.pptx
@@ -3842,158 +3842,302 @@
       </p:sp>
       <p:sp>
         <p:nvSpPr>
-          <p:cNvPr id="4" name="TextBox 3"/>
-          <p:cNvSpPr txBox="1"/>
-          <p:nvPr/>
-        </p:nvSpPr>
-        <p:spPr>
-          <a:xfrm>
-            <a:off x="822960" y="1261872"/>
-            <a:ext cx="10698480" cy="4251960"/>
-          </a:xfrm>
-          <a:prstGeom prst="rect">
-            <a:avLst/>
-          </a:prstGeom>
-          <a:noFill/>
-        </p:spPr>
-        <p:txBody>
-          <a:bodyPr wrap="square">
-            <a:normAutofit/>
-          </a:bodyPr>
-          <a:lstStyle/>
-          <a:p>
-            <a:pPr>
-              <a:spcAft>
-                <a:spcPts val="800"/>
-              </a:spcAft>
-              <a:defRPr sz="2100">
-                <a:solidFill>
-                  <a:srgbClr val="212529"/>
-                </a:solidFill>
-                <a:latin typeface="Pretendard"/>
-              </a:defRPr>
-            </a:pPr>
-            <a:r>
-              <a:t>고객을 마지막 행동 기준으로 bucket화합니다.</a:t>
-            </a:r>
-          </a:p>
-          <a:p>
-            <a:pPr>
-              <a:spcAft>
-                <a:spcPts val="800"/>
-              </a:spcAft>
-              <a:defRPr sz="2100">
-                <a:solidFill>
-                  <a:srgbClr val="212529"/>
-                </a:solidFill>
-                <a:latin typeface="Pretendard"/>
-              </a:defRPr>
-            </a:pPr>
-            <a:r>
-              <a:t>Bucket / 의미</a:t>
-            </a:r>
-          </a:p>
-          <a:p>
-            <a:pPr>
-              <a:spcAft>
-                <a:spcPts val="800"/>
-              </a:spcAft>
-              <a:defRPr sz="2100">
-                <a:solidFill>
-                  <a:srgbClr val="212529"/>
-                </a:solidFill>
-                <a:latin typeface="Pretendard"/>
-              </a:defRPr>
-            </a:pPr>
-            <a:r>
-              <a:t>0–30일 / 매우 최근 행동</a:t>
-            </a:r>
-          </a:p>
-          <a:p>
-            <a:pPr>
-              <a:spcAft>
-                <a:spcPts val="800"/>
-              </a:spcAft>
-              <a:defRPr sz="2100">
-                <a:solidFill>
-                  <a:srgbClr val="212529"/>
-                </a:solidFill>
-                <a:latin typeface="Pretendard"/>
-              </a:defRPr>
-            </a:pPr>
-            <a:r>
-              <a:t>31–60일 / 최근 행동</a:t>
-            </a:r>
-          </a:p>
-          <a:p>
-            <a:pPr>
-              <a:spcAft>
-                <a:spcPts val="800"/>
-              </a:spcAft>
-              <a:defRPr sz="2100">
-                <a:solidFill>
-                  <a:srgbClr val="212529"/>
-                </a:solidFill>
-                <a:latin typeface="Pretendard"/>
-              </a:defRPr>
-            </a:pPr>
-            <a:r>
-              <a:t>61–90일 / 약한 비활성 신호</a:t>
-            </a:r>
-          </a:p>
-          <a:p>
-            <a:pPr>
-              <a:spcAft>
-                <a:spcPts val="800"/>
-              </a:spcAft>
-              <a:defRPr sz="2100">
-                <a:solidFill>
-                  <a:srgbClr val="212529"/>
-                </a:solidFill>
-                <a:latin typeface="Pretendard"/>
-              </a:defRPr>
-            </a:pPr>
-            <a:r>
-              <a:t>91–120일 / 이탈 위험 증가</a:t>
-            </a:r>
-          </a:p>
-          <a:p>
-            <a:pPr>
-              <a:spcAft>
-                <a:spcPts val="800"/>
-              </a:spcAft>
-              <a:defRPr sz="2100">
-                <a:solidFill>
-                  <a:srgbClr val="212529"/>
-                </a:solidFill>
-                <a:latin typeface="Pretendard"/>
-              </a:defRPr>
-            </a:pPr>
-            <a:r>
-              <a:t>121–180일 / 강한 이탈 위험</a:t>
-            </a:r>
-          </a:p>
-          <a:p>
-            <a:pPr>
-              <a:spcAft>
-                <a:spcPts val="800"/>
-              </a:spcAft>
-              <a:defRPr sz="2100">
-                <a:solidFill>
-                  <a:srgbClr val="212529"/>
-                </a:solidFill>
-                <a:latin typeface="Pretendard"/>
-              </a:defRPr>
-            </a:pPr>
-            <a:r>
-              <a:t>181일+ / 재획득 또는 prospect 후보</a:t>
-            </a:r>
+          <p:cNvPr id="4" name="Rectangle 3"/>
+          <p:cNvSpPr/>
+          <p:nvPr/>
+        </p:nvSpPr>
+        <p:spPr>
+          <a:xfrm>
+            <a:off x="685800" y="1261872"/>
+            <a:ext cx="10835640" cy="685800"/>
+          </a:xfrm>
+          <a:prstGeom prst="rect">
+            <a:avLst/>
+          </a:prstGeom>
+          <a:solidFill>
+            <a:srgbClr val="FFF7E6"/>
+          </a:solidFill>
+          <a:ln>
+            <a:solidFill>
+              <a:srgbClr val="FF9900"/>
+            </a:solidFill>
+          </a:ln>
+        </p:spPr>
+        <p:style>
+          <a:lnRef idx="1">
+            <a:schemeClr val="accent1"/>
+          </a:lnRef>
+          <a:fillRef idx="3">
+            <a:schemeClr val="accent1"/>
+          </a:fillRef>
+          <a:effectRef idx="2">
+            <a:schemeClr val="accent1"/>
+          </a:effectRef>
+          <a:fontRef idx="minor">
+            <a:schemeClr val="lt1"/>
+          </a:fontRef>
+        </p:style>
+        <p:txBody>
+          <a:bodyPr rtlCol="0" anchor="ctr"/>
+          <a:lstStyle/>
+          <a:p>
+            <a:pPr algn="ctr"/>
           </a:p>
         </p:txBody>
       </p:sp>
       <p:sp>
         <p:nvSpPr>
           <p:cNvPr id="5" name="TextBox 4"/>
+          <p:cNvSpPr txBox="1"/>
+          <p:nvPr/>
+        </p:nvSpPr>
+        <p:spPr>
+          <a:xfrm>
+            <a:off x="914400" y="1380744"/>
+            <a:ext cx="10287000" cy="384048"/>
+          </a:xfrm>
+          <a:prstGeom prst="rect">
+            <a:avLst/>
+          </a:prstGeom>
+          <a:noFill/>
+        </p:spPr>
+        <p:txBody>
+          <a:bodyPr wrap="square">
+            <a:normAutofit/>
+          </a:bodyPr>
+          <a:lstStyle/>
+          <a:p>
+            <a:r>
+              <a:rPr sz="2100" b="1">
+                <a:solidFill>
+                  <a:srgbClr val="3B2A00"/>
+                </a:solidFill>
+                <a:latin typeface="Pretendard"/>
+              </a:rPr>
+              <a:t>처음에는 단순하게 나누고, 실제 반응률과 profit을 보며 조정합니다.</a:t>
+            </a:r>
+          </a:p>
+        </p:txBody>
+      </p:sp>
+      <p:sp>
+        <p:nvSpPr>
+          <p:cNvPr id="6" name="TextBox 5"/>
+          <p:cNvSpPr txBox="1"/>
+          <p:nvPr/>
+        </p:nvSpPr>
+        <p:spPr>
+          <a:xfrm>
+            <a:off x="777240" y="2157984"/>
+            <a:ext cx="5989320" cy="4343400"/>
+          </a:xfrm>
+          <a:prstGeom prst="rect">
+            <a:avLst/>
+          </a:prstGeom>
+          <a:noFill/>
+        </p:spPr>
+        <p:txBody>
+          <a:bodyPr wrap="square">
+            <a:normAutofit/>
+          </a:bodyPr>
+          <a:lstStyle/>
+          <a:p>
+            <a:pPr>
+              <a:spcAft>
+                <a:spcPts val="800"/>
+              </a:spcAft>
+              <a:defRPr sz="1900">
+                <a:solidFill>
+                  <a:srgbClr val="212529"/>
+                </a:solidFill>
+                <a:latin typeface="Pretendard"/>
+              </a:defRPr>
+            </a:pPr>
+            <a:r>
+              <a:t>고객을 마지막 행동 기준으로 3개 상태로 먼저 나눕니다.</a:t>
+            </a:r>
+          </a:p>
+          <a:p>
+            <a:pPr>
+              <a:spcAft>
+                <a:spcPts val="800"/>
+              </a:spcAft>
+              <a:defRPr sz="1900">
+                <a:solidFill>
+                  <a:srgbClr val="212529"/>
+                </a:solidFill>
+                <a:latin typeface="Pretendard"/>
+              </a:defRPr>
+            </a:pPr>
+            <a:r>
+              <a:t>상태 / Bucket / 운영 의미</a:t>
+            </a:r>
+          </a:p>
+          <a:p>
+            <a:pPr>
+              <a:spcAft>
+                <a:spcPts val="800"/>
+              </a:spcAft>
+              <a:defRPr sz="1900">
+                <a:solidFill>
+                  <a:srgbClr val="212529"/>
+                </a:solidFill>
+                <a:latin typeface="Pretendard"/>
+              </a:defRPr>
+            </a:pPr>
+            <a:r>
+              <a:t>Warm / 0–60일 / 반응 가능성이 높은 고객</a:t>
+            </a:r>
+          </a:p>
+          <a:p>
+            <a:pPr>
+              <a:spcAft>
+                <a:spcPts val="800"/>
+              </a:spcAft>
+              <a:defRPr sz="1900">
+                <a:solidFill>
+                  <a:srgbClr val="212529"/>
+                </a:solidFill>
+                <a:latin typeface="Pretendard"/>
+              </a:defRPr>
+            </a:pPr>
+            <a:r>
+              <a:t>Cooling / 61–120일 / 이탈 위험이 커지는 고객</a:t>
+            </a:r>
+          </a:p>
+          <a:p>
+            <a:pPr>
+              <a:spcAft>
+                <a:spcPts val="800"/>
+              </a:spcAft>
+              <a:defRPr sz="1900">
+                <a:solidFill>
+                  <a:srgbClr val="212529"/>
+                </a:solidFill>
+                <a:latin typeface="Pretendard"/>
+              </a:defRPr>
+            </a:pPr>
+            <a:r>
+              <a:t>Cold / 121일+ / 강한 이탈 위험 또는 재획득 후보</a:t>
+            </a:r>
+          </a:p>
+        </p:txBody>
+      </p:sp>
+      <p:sp>
+        <p:nvSpPr>
+          <p:cNvPr id="7" name="Rectangle 6"/>
+          <p:cNvSpPr/>
+          <p:nvPr/>
+        </p:nvSpPr>
+        <p:spPr>
+          <a:xfrm>
+            <a:off x="7086600" y="2157984"/>
+            <a:ext cx="4389120" cy="3246120"/>
+          </a:xfrm>
+          <a:prstGeom prst="rect">
+            <a:avLst/>
+          </a:prstGeom>
+          <a:solidFill>
+            <a:srgbClr val="EFF6FF"/>
+          </a:solidFill>
+          <a:ln>
+            <a:solidFill>
+              <a:srgbClr val="BFDBFE"/>
+            </a:solidFill>
+          </a:ln>
+        </p:spPr>
+        <p:style>
+          <a:lnRef idx="1">
+            <a:schemeClr val="accent1"/>
+          </a:lnRef>
+          <a:fillRef idx="3">
+            <a:schemeClr val="accent1"/>
+          </a:fillRef>
+          <a:effectRef idx="2">
+            <a:schemeClr val="accent1"/>
+          </a:effectRef>
+          <a:fontRef idx="minor">
+            <a:schemeClr val="lt1"/>
+          </a:fontRef>
+        </p:style>
+        <p:txBody>
+          <a:bodyPr rtlCol="0" anchor="ctr"/>
+          <a:lstStyle/>
+          <a:p>
+            <a:pPr algn="ctr"/>
+          </a:p>
+        </p:txBody>
+      </p:sp>
+      <p:sp>
+        <p:nvSpPr>
+          <p:cNvPr id="8" name="TextBox 7"/>
+          <p:cNvSpPr txBox="1"/>
+          <p:nvPr/>
+        </p:nvSpPr>
+        <p:spPr>
+          <a:xfrm>
+            <a:off x="7360920" y="2386584"/>
+            <a:ext cx="3840480" cy="320040"/>
+          </a:xfrm>
+          <a:prstGeom prst="rect">
+            <a:avLst/>
+          </a:prstGeom>
+          <a:noFill/>
+        </p:spPr>
+        <p:txBody>
+          <a:bodyPr wrap="square">
+            <a:normAutofit/>
+          </a:bodyPr>
+          <a:lstStyle/>
+          <a:p>
+            <a:r>
+              <a:rPr sz="1600" b="1">
+                <a:solidFill>
+                  <a:srgbClr val="007BFF"/>
+                </a:solidFill>
+                <a:latin typeface="Pretendard"/>
+              </a:rPr>
+              <a:t>Visual Guide</a:t>
+            </a:r>
+          </a:p>
+        </p:txBody>
+      </p:sp>
+      <p:sp>
+        <p:nvSpPr>
+          <p:cNvPr id="9" name="TextBox 8"/>
+          <p:cNvSpPr txBox="1"/>
+          <p:nvPr/>
+        </p:nvSpPr>
+        <p:spPr>
+          <a:xfrm>
+            <a:off x="7360920" y="2843784"/>
+            <a:ext cx="3794760" cy="2057400"/>
+          </a:xfrm>
+          <a:prstGeom prst="rect">
+            <a:avLst/>
+          </a:prstGeom>
+          <a:noFill/>
+        </p:spPr>
+        <p:txBody>
+          <a:bodyPr wrap="square">
+            <a:normAutofit/>
+          </a:bodyPr>
+          <a:lstStyle/>
+          <a:p>
+            <a:r>
+              <a:rPr sz="1600" b="0">
+                <a:solidFill>
+                  <a:srgbClr val="0B2D5B"/>
+                </a:solidFill>
+                <a:latin typeface="Pretendard"/>
+              </a:rPr>
+              <a:t>Warm → Cooling → Cold 3단계 온도계형 bucket 도식</a:t>
+            </a:r>
+          </a:p>
+        </p:txBody>
+      </p:sp>
+      <p:sp>
+        <p:nvSpPr>
+          <p:cNvPr id="10" name="TextBox 9"/>
           <p:cNvSpPr txBox="1"/>
           <p:nvPr/>
         </p:nvSpPr>
@@ -4216,168 +4360,217 @@
         </p:nvSpPr>
         <p:spPr>
           <a:xfrm>
-            <a:off x="822960" y="2157984"/>
-            <a:ext cx="10698480" cy="4251960"/>
-          </a:xfrm>
-          <a:prstGeom prst="rect">
-            <a:avLst/>
-          </a:prstGeom>
-          <a:noFill/>
-        </p:spPr>
-        <p:txBody>
-          <a:bodyPr wrap="square">
-            <a:normAutofit/>
-          </a:bodyPr>
-          <a:lstStyle/>
-          <a:p>
-            <a:pPr>
-              <a:spcAft>
-                <a:spcPts val="800"/>
-              </a:spcAft>
-              <a:defRPr sz="2100">
-                <a:solidFill>
-                  <a:srgbClr val="212529"/>
-                </a:solidFill>
-                <a:latin typeface="Pretendard"/>
-              </a:defRPr>
-            </a:pPr>
-            <a:r>
-              <a:t>Online Retail 사례에서 고객 분포는 이렇게 보였습니다.</a:t>
-            </a:r>
-          </a:p>
-          <a:p>
-            <a:pPr>
-              <a:spcAft>
-                <a:spcPts val="800"/>
-              </a:spcAft>
-              <a:defRPr sz="2100">
-                <a:solidFill>
-                  <a:srgbClr val="212529"/>
-                </a:solidFill>
-                <a:latin typeface="Pretendard"/>
-              </a:defRPr>
-            </a:pPr>
-            <a:r>
-              <a:t>마지막 구매 이후 / 전체 고객 비중</a:t>
-            </a:r>
-          </a:p>
-          <a:p>
-            <a:pPr>
-              <a:spcAft>
-                <a:spcPts val="800"/>
-              </a:spcAft>
-              <a:defRPr sz="2100">
-                <a:solidFill>
-                  <a:srgbClr val="212529"/>
-                </a:solidFill>
-                <a:latin typeface="Pretendard"/>
-              </a:defRPr>
-            </a:pPr>
-            <a:r>
-              <a:t>0–30일 / 3%</a:t>
-            </a:r>
-          </a:p>
-          <a:p>
-            <a:pPr>
-              <a:spcAft>
-                <a:spcPts val="800"/>
-              </a:spcAft>
-              <a:defRPr sz="2100">
-                <a:solidFill>
-                  <a:srgbClr val="212529"/>
-                </a:solidFill>
-                <a:latin typeface="Pretendard"/>
-              </a:defRPr>
-            </a:pPr>
-            <a:r>
-              <a:t>31–60일 / 6%</a:t>
-            </a:r>
-          </a:p>
-          <a:p>
-            <a:pPr>
-              <a:spcAft>
-                <a:spcPts val="800"/>
-              </a:spcAft>
-              <a:defRPr sz="2100">
-                <a:solidFill>
-                  <a:srgbClr val="212529"/>
-                </a:solidFill>
-                <a:latin typeface="Pretendard"/>
-              </a:defRPr>
-            </a:pPr>
-            <a:r>
-              <a:t>61–90일 / 10%</a:t>
-            </a:r>
-          </a:p>
-          <a:p>
-            <a:pPr>
-              <a:spcAft>
-                <a:spcPts val="800"/>
-              </a:spcAft>
-              <a:defRPr sz="2100">
-                <a:solidFill>
-                  <a:srgbClr val="212529"/>
-                </a:solidFill>
-                <a:latin typeface="Pretendard"/>
-              </a:defRPr>
-            </a:pPr>
-            <a:r>
-              <a:t>91–120일 / 14%</a:t>
-            </a:r>
-          </a:p>
-          <a:p>
-            <a:pPr>
-              <a:spcAft>
-                <a:spcPts val="800"/>
-              </a:spcAft>
-              <a:defRPr sz="2100">
-                <a:solidFill>
-                  <a:srgbClr val="212529"/>
-                </a:solidFill>
-                <a:latin typeface="Pretendard"/>
-              </a:defRPr>
-            </a:pPr>
-            <a:r>
-              <a:t>121–150일 / 16%</a:t>
-            </a:r>
-          </a:p>
-          <a:p>
-            <a:pPr>
-              <a:spcAft>
-                <a:spcPts val="800"/>
-              </a:spcAft>
-              <a:defRPr sz="2100">
-                <a:solidFill>
-                  <a:srgbClr val="212529"/>
-                </a:solidFill>
-                <a:latin typeface="Pretendard"/>
-              </a:defRPr>
-            </a:pPr>
-            <a:r>
-              <a:t>151–180일 / 20%</a:t>
-            </a:r>
-          </a:p>
-          <a:p>
-            <a:pPr>
-              <a:spcAft>
-                <a:spcPts val="800"/>
-              </a:spcAft>
-              <a:defRPr sz="2100">
-                <a:solidFill>
-                  <a:srgbClr val="212529"/>
-                </a:solidFill>
-                <a:latin typeface="Pretendard"/>
-              </a:defRPr>
-            </a:pPr>
-            <a:r>
-              <a:t>181일+ / 31%</a:t>
-            </a:r>
-          </a:p>
-        </p:txBody>
-      </p:sp>
-      <p:sp>
-        <p:nvSpPr>
-          <p:cNvPr id="7" name="TextBox 6"/>
+            <a:off x="777240" y="2157984"/>
+            <a:ext cx="5989320" cy="4343400"/>
+          </a:xfrm>
+          <a:prstGeom prst="rect">
+            <a:avLst/>
+          </a:prstGeom>
+          <a:noFill/>
+        </p:spPr>
+        <p:txBody>
+          <a:bodyPr wrap="square">
+            <a:normAutofit/>
+          </a:bodyPr>
+          <a:lstStyle/>
+          <a:p>
+            <a:pPr>
+              <a:spcAft>
+                <a:spcPts val="800"/>
+              </a:spcAft>
+              <a:defRPr sz="1900">
+                <a:solidFill>
+                  <a:srgbClr val="212529"/>
+                </a:solidFill>
+                <a:latin typeface="Pretendard"/>
+              </a:defRPr>
+            </a:pPr>
+            <a:r>
+              <a:t>Online Retail 사례에서 고객 기반은 오래된 고객 쪽으로 밀려 있었습니다.</a:t>
+            </a:r>
+          </a:p>
+          <a:p>
+            <a:pPr>
+              <a:spcAft>
+                <a:spcPts val="800"/>
+              </a:spcAft>
+              <a:defRPr sz="1900">
+                <a:solidFill>
+                  <a:srgbClr val="212529"/>
+                </a:solidFill>
+                <a:latin typeface="Pretendard"/>
+              </a:defRPr>
+            </a:pPr>
+            <a:r>
+              <a:t>구간 / 전체 고객 비중 / 해석</a:t>
+            </a:r>
+          </a:p>
+          <a:p>
+            <a:pPr>
+              <a:spcAft>
+                <a:spcPts val="800"/>
+              </a:spcAft>
+              <a:defRPr sz="1900">
+                <a:solidFill>
+                  <a:srgbClr val="212529"/>
+                </a:solidFill>
+                <a:latin typeface="Pretendard"/>
+              </a:defRPr>
+            </a:pPr>
+            <a:r>
+              <a:t>0–60일 / 9% / 최근 구매 고객은 소수</a:t>
+            </a:r>
+          </a:p>
+          <a:p>
+            <a:pPr>
+              <a:spcAft>
+                <a:spcPts val="800"/>
+              </a:spcAft>
+              <a:defRPr sz="1900">
+                <a:solidFill>
+                  <a:srgbClr val="212529"/>
+                </a:solidFill>
+                <a:latin typeface="Pretendard"/>
+              </a:defRPr>
+            </a:pPr>
+            <a:r>
+              <a:t>61–120일 / 24% / 위험 전환 구간</a:t>
+            </a:r>
+          </a:p>
+          <a:p>
+            <a:pPr>
+              <a:spcAft>
+                <a:spcPts val="800"/>
+              </a:spcAft>
+              <a:defRPr sz="1900">
+                <a:solidFill>
+                  <a:srgbClr val="212529"/>
+                </a:solidFill>
+                <a:latin typeface="Pretendard"/>
+              </a:defRPr>
+            </a:pPr>
+            <a:r>
+              <a:t>121일+ / 67% / 오래된 고객이 대부분</a:t>
+            </a:r>
+          </a:p>
+        </p:txBody>
+      </p:sp>
+      <p:sp>
+        <p:nvSpPr>
+          <p:cNvPr id="7" name="Rectangle 6"/>
+          <p:cNvSpPr/>
+          <p:nvPr/>
+        </p:nvSpPr>
+        <p:spPr>
+          <a:xfrm>
+            <a:off x="7086600" y="2157984"/>
+            <a:ext cx="4389120" cy="3246120"/>
+          </a:xfrm>
+          <a:prstGeom prst="rect">
+            <a:avLst/>
+          </a:prstGeom>
+          <a:solidFill>
+            <a:srgbClr val="EFF6FF"/>
+          </a:solidFill>
+          <a:ln>
+            <a:solidFill>
+              <a:srgbClr val="BFDBFE"/>
+            </a:solidFill>
+          </a:ln>
+        </p:spPr>
+        <p:style>
+          <a:lnRef idx="1">
+            <a:schemeClr val="accent1"/>
+          </a:lnRef>
+          <a:fillRef idx="3">
+            <a:schemeClr val="accent1"/>
+          </a:fillRef>
+          <a:effectRef idx="2">
+            <a:schemeClr val="accent1"/>
+          </a:effectRef>
+          <a:fontRef idx="minor">
+            <a:schemeClr val="lt1"/>
+          </a:fontRef>
+        </p:style>
+        <p:txBody>
+          <a:bodyPr rtlCol="0" anchor="ctr"/>
+          <a:lstStyle/>
+          <a:p>
+            <a:pPr algn="ctr"/>
+          </a:p>
+        </p:txBody>
+      </p:sp>
+      <p:sp>
+        <p:nvSpPr>
+          <p:cNvPr id="8" name="TextBox 7"/>
+          <p:cNvSpPr txBox="1"/>
+          <p:nvPr/>
+        </p:nvSpPr>
+        <p:spPr>
+          <a:xfrm>
+            <a:off x="7360920" y="2386584"/>
+            <a:ext cx="3840480" cy="320040"/>
+          </a:xfrm>
+          <a:prstGeom prst="rect">
+            <a:avLst/>
+          </a:prstGeom>
+          <a:noFill/>
+        </p:spPr>
+        <p:txBody>
+          <a:bodyPr wrap="square">
+            <a:normAutofit/>
+          </a:bodyPr>
+          <a:lstStyle/>
+          <a:p>
+            <a:r>
+              <a:rPr sz="1600" b="1">
+                <a:solidFill>
+                  <a:srgbClr val="007BFF"/>
+                </a:solidFill>
+                <a:latin typeface="Pretendard"/>
+              </a:rPr>
+              <a:t>Visual Guide</a:t>
+            </a:r>
+          </a:p>
+        </p:txBody>
+      </p:sp>
+      <p:sp>
+        <p:nvSpPr>
+          <p:cNvPr id="9" name="TextBox 8"/>
+          <p:cNvSpPr txBox="1"/>
+          <p:nvPr/>
+        </p:nvSpPr>
+        <p:spPr>
+          <a:xfrm>
+            <a:off x="7360920" y="2843784"/>
+            <a:ext cx="3794760" cy="2057400"/>
+          </a:xfrm>
+          <a:prstGeom prst="rect">
+            <a:avLst/>
+          </a:prstGeom>
+          <a:noFill/>
+        </p:spPr>
+        <p:txBody>
+          <a:bodyPr wrap="square">
+            <a:normAutofit/>
+          </a:bodyPr>
+          <a:lstStyle/>
+          <a:p>
+            <a:r>
+              <a:rPr sz="1600" b="0">
+                <a:solidFill>
+                  <a:srgbClr val="0B2D5B"/>
+                </a:solidFill>
+                <a:latin typeface="Pretendard"/>
+              </a:rPr>
+              <a:t>0–60 / 61–120 / 121+ 비중을 보여주는 100% stacked bar</a:t>
+            </a:r>
+          </a:p>
+        </p:txBody>
+      </p:sp>
+      <p:sp>
+        <p:nvSpPr>
+          <p:cNvPr id="10" name="TextBox 9"/>
           <p:cNvSpPr txBox="1"/>
           <p:nvPr/>
         </p:nvSpPr>
@@ -4600,57 +4793,57 @@
         </p:nvSpPr>
         <p:spPr>
           <a:xfrm>
-            <a:off x="822960" y="2157984"/>
-            <a:ext cx="10698480" cy="4251960"/>
-          </a:xfrm>
-          <a:prstGeom prst="rect">
-            <a:avLst/>
-          </a:prstGeom>
-          <a:noFill/>
-        </p:spPr>
-        <p:txBody>
-          <a:bodyPr wrap="square">
-            <a:normAutofit/>
-          </a:bodyPr>
-          <a:lstStyle/>
-          <a:p>
-            <a:pPr>
-              <a:spcAft>
-                <a:spcPts val="800"/>
-              </a:spcAft>
-              <a:defRPr sz="2100">
-                <a:solidFill>
-                  <a:srgbClr val="212529"/>
-                </a:solidFill>
-                <a:latin typeface="Pretendard"/>
-              </a:defRPr>
-            </a:pPr>
-            <a:r>
-              <a:t>같은 사례에서 newsletter responders를 보면 패턴이 뒤집힙니다.</a:t>
-            </a:r>
-          </a:p>
-          <a:p>
-            <a:pPr>
-              <a:spcAft>
-                <a:spcPts val="800"/>
-              </a:spcAft>
-              <a:defRPr sz="2100">
-                <a:solidFill>
-                  <a:srgbClr val="212529"/>
-                </a:solidFill>
-                <a:latin typeface="Pretendard"/>
-              </a:defRPr>
-            </a:pPr>
-            <a:r>
-              <a:t>마지막 구매 이후 / 전체 고객 / 응답자</a:t>
-            </a:r>
-          </a:p>
-          <a:p>
-            <a:pPr>
-              <a:spcAft>
-                <a:spcPts val="800"/>
-              </a:spcAft>
-              <a:defRPr sz="2100">
+            <a:off x="777240" y="2157984"/>
+            <a:ext cx="5989320" cy="4343400"/>
+          </a:xfrm>
+          <a:prstGeom prst="rect">
+            <a:avLst/>
+          </a:prstGeom>
+          <a:noFill/>
+        </p:spPr>
+        <p:txBody>
+          <a:bodyPr wrap="square">
+            <a:normAutofit/>
+          </a:bodyPr>
+          <a:lstStyle/>
+          <a:p>
+            <a:pPr>
+              <a:spcAft>
+                <a:spcPts val="800"/>
+              </a:spcAft>
+              <a:defRPr sz="1900">
+                <a:solidFill>
+                  <a:srgbClr val="212529"/>
+                </a:solidFill>
+                <a:latin typeface="Pretendard"/>
+              </a:defRPr>
+            </a:pPr>
+            <a:r>
+              <a:t>같은 고객 기반에서도 응답자는 최근 구매 고객에 몰려 있었습니다.</a:t>
+            </a:r>
+          </a:p>
+          <a:p>
+            <a:pPr>
+              <a:spcAft>
+                <a:spcPts val="800"/>
+              </a:spcAft>
+              <a:defRPr sz="1900">
+                <a:solidFill>
+                  <a:srgbClr val="212529"/>
+                </a:solidFill>
+                <a:latin typeface="Pretendard"/>
+              </a:defRPr>
+            </a:pPr>
+            <a:r>
+              <a:t>비교 / 전체 고객 / 응답자</a:t>
+            </a:r>
+          </a:p>
+          <a:p>
+            <a:pPr>
+              <a:spcAft>
+                <a:spcPts val="800"/>
+              </a:spcAft>
+              <a:defRPr sz="1900">
                 <a:solidFill>
                   <a:srgbClr val="212529"/>
                 </a:solidFill>
@@ -4666,87 +4859,23 @@
               <a:spcAft>
                 <a:spcPts val="800"/>
               </a:spcAft>
-              <a:defRPr sz="2100">
-                <a:solidFill>
-                  <a:srgbClr val="212529"/>
-                </a:solidFill>
-                <a:latin typeface="Pretendard"/>
-              </a:defRPr>
-            </a:pPr>
-            <a:r>
-              <a:t>31–60일 / 6% / 18%</a:t>
-            </a:r>
-          </a:p>
-          <a:p>
-            <a:pPr>
-              <a:spcAft>
-                <a:spcPts val="800"/>
-              </a:spcAft>
-              <a:defRPr sz="2100">
-                <a:solidFill>
-                  <a:srgbClr val="212529"/>
-                </a:solidFill>
-                <a:latin typeface="Pretendard"/>
-              </a:defRPr>
-            </a:pPr>
-            <a:r>
-              <a:t>61–90일 / 10% / 18%</a:t>
-            </a:r>
-          </a:p>
-          <a:p>
-            <a:pPr>
-              <a:spcAft>
-                <a:spcPts val="800"/>
-              </a:spcAft>
-              <a:defRPr sz="2100">
-                <a:solidFill>
-                  <a:srgbClr val="212529"/>
-                </a:solidFill>
-                <a:latin typeface="Pretendard"/>
-              </a:defRPr>
-            </a:pPr>
-            <a:r>
-              <a:t>91–120일 / 14% / 14%</a:t>
-            </a:r>
-          </a:p>
-          <a:p>
-            <a:pPr>
-              <a:spcAft>
-                <a:spcPts val="800"/>
-              </a:spcAft>
-              <a:defRPr sz="2100">
-                <a:solidFill>
-                  <a:srgbClr val="212529"/>
-                </a:solidFill>
-                <a:latin typeface="Pretendard"/>
-              </a:defRPr>
-            </a:pPr>
-            <a:r>
-              <a:t>121–150일 / 16% / 10%</a:t>
-            </a:r>
-          </a:p>
-          <a:p>
-            <a:pPr>
-              <a:spcAft>
-                <a:spcPts val="800"/>
-              </a:spcAft>
-              <a:defRPr sz="2100">
-                <a:solidFill>
-                  <a:srgbClr val="212529"/>
-                </a:solidFill>
-                <a:latin typeface="Pretendard"/>
-              </a:defRPr>
-            </a:pPr>
-            <a:r>
-              <a:t>151–180일 / 20% / 6%</a:t>
-            </a:r>
-          </a:p>
-          <a:p>
-            <a:pPr>
-              <a:spcAft>
-                <a:spcPts val="800"/>
-              </a:spcAft>
-              <a:defRPr sz="2100">
+              <a:defRPr sz="1900">
+                <a:solidFill>
+                  <a:srgbClr val="212529"/>
+                </a:solidFill>
+                <a:latin typeface="Pretendard"/>
+              </a:defRPr>
+            </a:pPr>
+            <a:r>
+              <a:t>0–60일 누적 / 9% / 49%</a:t>
+            </a:r>
+          </a:p>
+          <a:p>
+            <a:pPr>
+              <a:spcAft>
+                <a:spcPts val="800"/>
+              </a:spcAft>
+              <a:defRPr sz="1900">
                 <a:solidFill>
                   <a:srgbClr val="212529"/>
                 </a:solidFill>
@@ -4761,7 +4890,120 @@
       </p:sp>
       <p:sp>
         <p:nvSpPr>
-          <p:cNvPr id="7" name="TextBox 6"/>
+          <p:cNvPr id="7" name="Rectangle 6"/>
+          <p:cNvSpPr/>
+          <p:nvPr/>
+        </p:nvSpPr>
+        <p:spPr>
+          <a:xfrm>
+            <a:off x="7086600" y="2157984"/>
+            <a:ext cx="4389120" cy="3246120"/>
+          </a:xfrm>
+          <a:prstGeom prst="rect">
+            <a:avLst/>
+          </a:prstGeom>
+          <a:solidFill>
+            <a:srgbClr val="EFF6FF"/>
+          </a:solidFill>
+          <a:ln>
+            <a:solidFill>
+              <a:srgbClr val="BFDBFE"/>
+            </a:solidFill>
+          </a:ln>
+        </p:spPr>
+        <p:style>
+          <a:lnRef idx="1">
+            <a:schemeClr val="accent1"/>
+          </a:lnRef>
+          <a:fillRef idx="3">
+            <a:schemeClr val="accent1"/>
+          </a:fillRef>
+          <a:effectRef idx="2">
+            <a:schemeClr val="accent1"/>
+          </a:effectRef>
+          <a:fontRef idx="minor">
+            <a:schemeClr val="lt1"/>
+          </a:fontRef>
+        </p:style>
+        <p:txBody>
+          <a:bodyPr rtlCol="0" anchor="ctr"/>
+          <a:lstStyle/>
+          <a:p>
+            <a:pPr algn="ctr"/>
+          </a:p>
+        </p:txBody>
+      </p:sp>
+      <p:sp>
+        <p:nvSpPr>
+          <p:cNvPr id="8" name="TextBox 7"/>
+          <p:cNvSpPr txBox="1"/>
+          <p:nvPr/>
+        </p:nvSpPr>
+        <p:spPr>
+          <a:xfrm>
+            <a:off x="7360920" y="2386584"/>
+            <a:ext cx="3840480" cy="320040"/>
+          </a:xfrm>
+          <a:prstGeom prst="rect">
+            <a:avLst/>
+          </a:prstGeom>
+          <a:noFill/>
+        </p:spPr>
+        <p:txBody>
+          <a:bodyPr wrap="square">
+            <a:normAutofit/>
+          </a:bodyPr>
+          <a:lstStyle/>
+          <a:p>
+            <a:r>
+              <a:rPr sz="1600" b="1">
+                <a:solidFill>
+                  <a:srgbClr val="007BFF"/>
+                </a:solidFill>
+                <a:latin typeface="Pretendard"/>
+              </a:rPr>
+              <a:t>Visual Guide</a:t>
+            </a:r>
+          </a:p>
+        </p:txBody>
+      </p:sp>
+      <p:sp>
+        <p:nvSpPr>
+          <p:cNvPr id="9" name="TextBox 8"/>
+          <p:cNvSpPr txBox="1"/>
+          <p:nvPr/>
+        </p:nvSpPr>
+        <p:spPr>
+          <a:xfrm>
+            <a:off x="7360920" y="2843784"/>
+            <a:ext cx="3794760" cy="2057400"/>
+          </a:xfrm>
+          <a:prstGeom prst="rect">
+            <a:avLst/>
+          </a:prstGeom>
+          <a:noFill/>
+        </p:spPr>
+        <p:txBody>
+          <a:bodyPr wrap="square">
+            <a:normAutofit/>
+          </a:bodyPr>
+          <a:lstStyle/>
+          <a:p>
+            <a:r>
+              <a:rPr sz="1600" b="0">
+                <a:solidFill>
+                  <a:srgbClr val="0B2D5B"/>
+                </a:solidFill>
+                <a:latin typeface="Pretendard"/>
+              </a:rPr>
+              <a:t>전체 고객 분포 vs 응답자 분포를 나란히 보여주는 mirrored bar</a:t>
+            </a:r>
+          </a:p>
+        </p:txBody>
+      </p:sp>
+      <p:sp>
+        <p:nvSpPr>
+          <p:cNvPr id="10" name="TextBox 9"/>
           <p:cNvSpPr txBox="1"/>
           <p:nvPr/>
         </p:nvSpPr>
@@ -6874,152 +7116,217 @@
         </p:nvSpPr>
         <p:spPr>
           <a:xfrm>
-            <a:off x="822960" y="2157984"/>
-            <a:ext cx="10698480" cy="4251960"/>
-          </a:xfrm>
-          <a:prstGeom prst="rect">
-            <a:avLst/>
-          </a:prstGeom>
-          <a:noFill/>
-        </p:spPr>
-        <p:txBody>
-          <a:bodyPr wrap="square">
-            <a:normAutofit/>
-          </a:bodyPr>
-          <a:lstStyle/>
-          <a:p>
-            <a:pPr>
-              <a:spcAft>
-                <a:spcPts val="800"/>
-              </a:spcAft>
-              <a:defRPr sz="2100">
-                <a:solidFill>
-                  <a:srgbClr val="212529"/>
-                </a:solidFill>
-                <a:latin typeface="Pretendard"/>
-              </a:defRPr>
-            </a:pPr>
-            <a:r>
-              <a:t>고객 행동 사이 간격을 순서대로 보면 LifeCycle이 드러납니다.</a:t>
-            </a:r>
-          </a:p>
-          <a:p>
-            <a:pPr>
-              <a:spcAft>
-                <a:spcPts val="800"/>
-              </a:spcAft>
-              <a:defRPr sz="2100">
-                <a:solidFill>
-                  <a:srgbClr val="212529"/>
-                </a:solidFill>
-                <a:latin typeface="Pretendard"/>
-              </a:defRPr>
-            </a:pPr>
-            <a:r>
-              <a:t>행동 간격 / 평균 Latency</a:t>
-            </a:r>
-          </a:p>
-          <a:p>
-            <a:pPr>
-              <a:spcAft>
-                <a:spcPts val="800"/>
-              </a:spcAft>
-              <a:defRPr sz="2100">
-                <a:solidFill>
-                  <a:srgbClr val="212529"/>
-                </a:solidFill>
-                <a:latin typeface="Pretendard"/>
-              </a:defRPr>
-            </a:pPr>
-            <a:r>
-              <a:t>1→2번째 행동 / 90일</a:t>
-            </a:r>
-          </a:p>
-          <a:p>
-            <a:pPr>
-              <a:spcAft>
-                <a:spcPts val="800"/>
-              </a:spcAft>
-              <a:defRPr sz="2100">
-                <a:solidFill>
-                  <a:srgbClr val="212529"/>
-                </a:solidFill>
-                <a:latin typeface="Pretendard"/>
-              </a:defRPr>
-            </a:pPr>
-            <a:r>
-              <a:t>2→3번째 행동 / 60일</a:t>
-            </a:r>
-          </a:p>
-          <a:p>
-            <a:pPr>
-              <a:spcAft>
-                <a:spcPts val="800"/>
-              </a:spcAft>
-              <a:defRPr sz="2100">
-                <a:solidFill>
-                  <a:srgbClr val="212529"/>
-                </a:solidFill>
-                <a:latin typeface="Pretendard"/>
-              </a:defRPr>
-            </a:pPr>
-            <a:r>
-              <a:t>3→4번째 행동 / 30일</a:t>
-            </a:r>
-          </a:p>
-          <a:p>
-            <a:pPr>
-              <a:spcAft>
-                <a:spcPts val="800"/>
-              </a:spcAft>
-              <a:defRPr sz="2100">
-                <a:solidFill>
-                  <a:srgbClr val="212529"/>
-                </a:solidFill>
-                <a:latin typeface="Pretendard"/>
-              </a:defRPr>
-            </a:pPr>
-            <a:r>
-              <a:t>4→5번째 행동 / 60일</a:t>
-            </a:r>
-          </a:p>
-          <a:p>
-            <a:pPr>
-              <a:spcAft>
-                <a:spcPts val="800"/>
-              </a:spcAft>
-              <a:defRPr sz="2100">
-                <a:solidFill>
-                  <a:srgbClr val="212529"/>
-                </a:solidFill>
-                <a:latin typeface="Pretendard"/>
-              </a:defRPr>
-            </a:pPr>
-            <a:r>
-              <a:t>5→6번째 행동 / 90일</a:t>
-            </a:r>
-          </a:p>
-          <a:p>
-            <a:pPr>
-              <a:spcAft>
-                <a:spcPts val="800"/>
-              </a:spcAft>
-              <a:defRPr sz="2100">
-                <a:solidFill>
-                  <a:srgbClr val="212529"/>
-                </a:solidFill>
-                <a:latin typeface="Pretendard"/>
-              </a:defRPr>
-            </a:pPr>
-            <a:r>
-              <a:t>6→7번째 행동 / 120일</a:t>
-            </a:r>
-          </a:p>
-        </p:txBody>
-      </p:sp>
-      <p:sp>
-        <p:nvSpPr>
-          <p:cNvPr id="7" name="TextBox 6"/>
+            <a:off x="777240" y="2157984"/>
+            <a:ext cx="5989320" cy="4343400"/>
+          </a:xfrm>
+          <a:prstGeom prst="rect">
+            <a:avLst/>
+          </a:prstGeom>
+          <a:noFill/>
+        </p:spPr>
+        <p:txBody>
+          <a:bodyPr wrap="square">
+            <a:normAutofit/>
+          </a:bodyPr>
+          <a:lstStyle/>
+          <a:p>
+            <a:pPr>
+              <a:spcAft>
+                <a:spcPts val="800"/>
+              </a:spcAft>
+              <a:defRPr sz="1900">
+                <a:solidFill>
+                  <a:srgbClr val="212529"/>
+                </a:solidFill>
+                <a:latin typeface="Pretendard"/>
+              </a:defRPr>
+            </a:pPr>
+            <a:r>
+              <a:t>행동 사이 간격은 고객 LifeCycle의 속도 변화를 보여줍니다.</a:t>
+            </a:r>
+          </a:p>
+          <a:p>
+            <a:pPr>
+              <a:spcAft>
+                <a:spcPts val="800"/>
+              </a:spcAft>
+              <a:defRPr sz="1900">
+                <a:solidFill>
+                  <a:srgbClr val="212529"/>
+                </a:solidFill>
+                <a:latin typeface="Pretendard"/>
+              </a:defRPr>
+            </a:pPr>
+            <a:r>
+              <a:t>구간 / 평균 Latency / 의미</a:t>
+            </a:r>
+          </a:p>
+          <a:p>
+            <a:pPr>
+              <a:spcAft>
+                <a:spcPts val="800"/>
+              </a:spcAft>
+              <a:defRPr sz="1900">
+                <a:solidFill>
+                  <a:srgbClr val="212529"/>
+                </a:solidFill>
+                <a:latin typeface="Pretendard"/>
+              </a:defRPr>
+            </a:pPr>
+            <a:r>
+              <a:t>1→2 / 90일 / 시작은 느림</a:t>
+            </a:r>
+          </a:p>
+          <a:p>
+            <a:pPr>
+              <a:spcAft>
+                <a:spcPts val="800"/>
+              </a:spcAft>
+              <a:defRPr sz="1900">
+                <a:solidFill>
+                  <a:srgbClr val="212529"/>
+                </a:solidFill>
+                <a:latin typeface="Pretendard"/>
+              </a:defRPr>
+            </a:pPr>
+            <a:r>
+              <a:t>2→4 / 60일 → 30일 / 관계가 가속</a:t>
+            </a:r>
+          </a:p>
+          <a:p>
+            <a:pPr>
+              <a:spcAft>
+                <a:spcPts val="800"/>
+              </a:spcAft>
+              <a:defRPr sz="1900">
+                <a:solidFill>
+                  <a:srgbClr val="212529"/>
+                </a:solidFill>
+                <a:latin typeface="Pretendard"/>
+              </a:defRPr>
+            </a:pPr>
+            <a:r>
+              <a:t>4→7 / 60일 → 120일 / 감속 시작</a:t>
+            </a:r>
+          </a:p>
+        </p:txBody>
+      </p:sp>
+      <p:sp>
+        <p:nvSpPr>
+          <p:cNvPr id="7" name="Rectangle 6"/>
+          <p:cNvSpPr/>
+          <p:nvPr/>
+        </p:nvSpPr>
+        <p:spPr>
+          <a:xfrm>
+            <a:off x="7086600" y="2157984"/>
+            <a:ext cx="4389120" cy="3246120"/>
+          </a:xfrm>
+          <a:prstGeom prst="rect">
+            <a:avLst/>
+          </a:prstGeom>
+          <a:solidFill>
+            <a:srgbClr val="EFF6FF"/>
+          </a:solidFill>
+          <a:ln>
+            <a:solidFill>
+              <a:srgbClr val="BFDBFE"/>
+            </a:solidFill>
+          </a:ln>
+        </p:spPr>
+        <p:style>
+          <a:lnRef idx="1">
+            <a:schemeClr val="accent1"/>
+          </a:lnRef>
+          <a:fillRef idx="3">
+            <a:schemeClr val="accent1"/>
+          </a:fillRef>
+          <a:effectRef idx="2">
+            <a:schemeClr val="accent1"/>
+          </a:effectRef>
+          <a:fontRef idx="minor">
+            <a:schemeClr val="lt1"/>
+          </a:fontRef>
+        </p:style>
+        <p:txBody>
+          <a:bodyPr rtlCol="0" anchor="ctr"/>
+          <a:lstStyle/>
+          <a:p>
+            <a:pPr algn="ctr"/>
+          </a:p>
+        </p:txBody>
+      </p:sp>
+      <p:sp>
+        <p:nvSpPr>
+          <p:cNvPr id="8" name="TextBox 7"/>
+          <p:cNvSpPr txBox="1"/>
+          <p:nvPr/>
+        </p:nvSpPr>
+        <p:spPr>
+          <a:xfrm>
+            <a:off x="7360920" y="2386584"/>
+            <a:ext cx="3840480" cy="320040"/>
+          </a:xfrm>
+          <a:prstGeom prst="rect">
+            <a:avLst/>
+          </a:prstGeom>
+          <a:noFill/>
+        </p:spPr>
+        <p:txBody>
+          <a:bodyPr wrap="square">
+            <a:normAutofit/>
+          </a:bodyPr>
+          <a:lstStyle/>
+          <a:p>
+            <a:r>
+              <a:rPr sz="1600" b="1">
+                <a:solidFill>
+                  <a:srgbClr val="007BFF"/>
+                </a:solidFill>
+                <a:latin typeface="Pretendard"/>
+              </a:rPr>
+              <a:t>Visual Guide</a:t>
+            </a:r>
+          </a:p>
+        </p:txBody>
+      </p:sp>
+      <p:sp>
+        <p:nvSpPr>
+          <p:cNvPr id="9" name="TextBox 8"/>
+          <p:cNvSpPr txBox="1"/>
+          <p:nvPr/>
+        </p:nvSpPr>
+        <p:spPr>
+          <a:xfrm>
+            <a:off x="7360920" y="2843784"/>
+            <a:ext cx="3794760" cy="2057400"/>
+          </a:xfrm>
+          <a:prstGeom prst="rect">
+            <a:avLst/>
+          </a:prstGeom>
+          <a:noFill/>
+        </p:spPr>
+        <p:txBody>
+          <a:bodyPr wrap="square">
+            <a:normAutofit/>
+          </a:bodyPr>
+          <a:lstStyle/>
+          <a:p>
+            <a:r>
+              <a:rPr sz="1600" b="0">
+                <a:solidFill>
+                  <a:srgbClr val="0B2D5B"/>
+                </a:solidFill>
+                <a:latin typeface="Pretendard"/>
+              </a:rPr>
+              <a:t>90 → 60 → 30 → 60 → 90 → 120 라인 차트, 4번째 행동 이후 turning point 강조</a:t>
+            </a:r>
+          </a:p>
+        </p:txBody>
+      </p:sp>
+      <p:sp>
+        <p:nvSpPr>
+          <p:cNvPr id="10" name="TextBox 9"/>
           <p:cNvSpPr txBox="1"/>
           <p:nvPr/>
         </p:nvSpPr>

</xml_diff>

<commit_message>
Reposition lecture for internal analyst methodology training
</commit_message>
<xml_diff>
--- a/recency-latency-retention-crm-lecture-full-workshop-v3-final.pptx
+++ b/recency-latency-retention-crm-lecture-full-workshop-v3-final.pptx
@@ -3254,7 +3254,7 @@
                 </a:solidFill>
                 <a:latin typeface="Pretendard"/>
               </a:rPr>
-              <a:t>고객 행동 데이터 기반 Recency / Latency 리텐션 분석과 CRM 자동화</a:t>
+              <a:t>내부 분석가를 위한 Recency / Latency 리텐션 분석 방법론</a:t>
             </a:r>
           </a:p>
         </p:txBody>
@@ -3298,7 +3298,7 @@
                   <a:srgbClr val="FFFFFF"/>
                 </a:solidFill>
               </a:rPr>
-              <a:t>대상: CRM / Growth / Product Analytics / Marketing 실무자</a:t>
+              <a:t>대상: 내부 분석가 / Product Analytics / CRM Analytics / Growth Analytics 담당자</a:t>
             </a:r>
           </a:p>
           <a:p>
@@ -3319,7 +3319,7 @@
                   <a:srgbClr val="FFFFFF"/>
                 </a:solidFill>
               </a:rPr>
-              <a:t>형식: 60~90분 강의용 슬라이드 원고 v3-final</a:t>
+              <a:t>형식: 내부 분석가 방법론 교육용 full workshop v3-final</a:t>
             </a:r>
           </a:p>
           <a:p>
@@ -11457,7 +11457,7 @@
                 </a:solidFill>
                 <a:latin typeface="Pretendard"/>
               </a:rPr>
-              <a:t>분석의 끝은 리포트가 아니라 개입 타이밍입니다.</a:t>
+              <a:t>분석의 끝은 리포트가 아니라 검증 가능한 의사결정입니다.</a:t>
             </a:r>
           </a:p>
         </p:txBody>
@@ -11560,7 +11560,7 @@
               </a:defRPr>
             </a:pPr>
             <a:r>
-              <a:t>CRM 캠페인을 Timing × Offer × Profit 관점으로 테스트한다</a:t>
+              <a:t>CRM/리텐션 분석을 Timing × Offer × Profit 관점으로 검증한다</a:t>
             </a:r>
           </a:p>
         </p:txBody>
@@ -12785,7 +12785,7 @@
                 </a:solidFill>
                 <a:latin typeface="Pretendard"/>
               </a:rPr>
-              <a:t>이 4개 리포트가 있으면 리텐션 CRM의 기반이 갖춰집니다.</a:t>
+              <a:t>이 4개 리포트가 있으면 분석가가 리텐션 문제를 진단하고 액션으로 연결할 기반이 갖춰집니다.</a:t>
             </a:r>
           </a:p>
         </p:txBody>
@@ -15097,7 +15097,7 @@
                 </a:solidFill>
                 <a:latin typeface="Pretendard"/>
               </a:rPr>
-              <a:t>자동화는 발송 룰이 아니라 측정 가능한 개입 시스템입니다.</a:t>
+              <a:t>분석 제안은 아이디어가 아니라 측정 가능한 개입 시스템이어야 합니다.</a:t>
             </a:r>
           </a:p>
         </p:txBody>
@@ -15136,7 +15136,7 @@
               </a:defRPr>
             </a:pPr>
             <a:r>
-              <a:t>CRM 자동화를 설계할 때 반드시 5가지를 명확히 합니다:</a:t>
+              <a:t>분석가가 CRM/리텐션 액션을 제안할 때 반드시 5가지를 명확히 합니다:</a:t>
             </a:r>
           </a:p>
           <a:p>
@@ -20196,7 +20196,7 @@
                 </a:solidFill>
                 <a:latin typeface="Pretendard"/>
               </a:rPr>
-              <a:t>작은 spreadsheet 하나로도 CRM ROI 구조는 바뀔 수 있습니다.</a:t>
+              <a:t>작은 spreadsheet 하나로도 분석 질문의 수준은 바뀔 수 있습니다.</a:t>
             </a:r>
           </a:p>
         </p:txBody>
@@ -20235,7 +20235,7 @@
               </a:defRPr>
             </a:pPr>
             <a:r>
-              <a:t>이번 주 실행 체크리스트:</a:t>
+              <a:t>내부 분석가 실무 적용 체크리스트:</a:t>
             </a:r>
           </a:p>
           <a:p>

</xml_diff>